<commit_message>
Deploy to a real Kubernetes cluster in CI, and fix the two bugs it exposed
A new CI job builds the image, loads it into a throwaway kind cluster and
applies deploy/kubernetes/ as written. With no MLflow in the cluster the pods
must stay alive but not ready, unrestarted and out of the Service; with a
model available the rollout must complete and /predict must answer through
the Service. Publishing now waits for it.

Checking that claim by hand first found it false twice:
- With MLflow unreachable, startup sat in MLflow's retry backoff for minutes
  with /health silent, so the startup probe would kill the pod forever.
  Registry loading now fails fast (2 retries, 10 s) unless overridden.
- /ready answered 200 with "degraded" in the body. Probes read only the
  status code, so a pod with no model took traffic. It now returns 503.

Also: a slide for the live pipeline.

Co-Authored-By: Claude Opus 5.5 <noreply@anthropic.com>
</commit_message>
<xml_diff>
--- a/docs/viva/slides.pptx
+++ b/docs/viva/slides.pptx
@@ -12,6 +12,7 @@
     <p:sldId id="260" r:id="rId6"/>
     <p:sldId id="261" r:id="rId7"/>
     <p:sldId id="262" r:id="rId8"/>
+    <p:sldId id="268" r:id="rId19"/>
     <p:sldId id="263" r:id="rId9"/>
     <p:sldId id="264" r:id="rId10"/>
     <p:sldId id="265" r:id="rId11"/>
@@ -1134,6 +1135,94 @@
             <a:fld id="{F7021451-1387-4CA6-816F-3879F97B5CBC}" type="slidenum">
               <a:rPr lang="en-US"/>
               <a:t>12</a:t>
+            </a:fld>
+            <a:endParaRPr lang="en-US"/>
+          </a:p>
+        </p:txBody>
+      </p:sp>
+    </p:spTree>
+    <p:extLst>
+      <p:ext uri="{BB962C8B-B14F-4D97-AF65-F5344CB8AC3E}">
+        <p14:creationId xmlns:p14="http://schemas.microsoft.com/office/powerpoint/2010/main" val="1024086991"/>
+      </p:ext>
+    </p:extLst>
+  </p:cSld>
+  <p:clrMapOvr>
+    <a:masterClrMapping/>
+  </p:clrMapOvr>
+</p:notes>
+</file>
+
+<file path=ppt/notesSlides/notesSlide13.xml><?xml version="1.0" encoding="utf-8"?>
+<p:notes xmlns:a="http://schemas.openxmlformats.org/drawingml/2006/main" xmlns:r="http://schemas.openxmlformats.org/officeDocument/2006/relationships" xmlns:p="http://schemas.openxmlformats.org/presentationml/2006/main">
+  <p:cSld>
+    <p:spTree>
+      <p:nvGrpSpPr>
+        <p:cNvPr id="1" name=""/>
+        <p:cNvGrpSpPr/>
+        <p:nvPr/>
+      </p:nvGrpSpPr>
+      <p:grpSpPr>
+        <a:xfrm>
+          <a:off x="0" y="0"/>
+          <a:ext cx="0" cy="0"/>
+          <a:chOff x="0" y="0"/>
+          <a:chExt cx="0" cy="0"/>
+        </a:xfrm>
+      </p:grpSpPr>
+      <p:sp>
+        <p:nvSpPr>
+          <p:cNvPr id="2" name="Slide Image Placeholder 1"/>
+          <p:cNvSpPr>
+            <a:spLocks noGrp="1" noRot="1" noChangeAspect="1"/>
+          </p:cNvSpPr>
+          <p:nvPr>
+            <p:ph type="sldImg"/>
+          </p:nvPr>
+        </p:nvSpPr>
+        <p:spPr/>
+      </p:sp>
+      <p:sp>
+        <p:nvSpPr>
+          <p:cNvPr id="3" name="Notes Placeholder 2"/>
+          <p:cNvSpPr>
+            <a:spLocks noGrp="1"/>
+          </p:cNvSpPr>
+          <p:nvPr>
+            <p:ph type="body" idx="1"/>
+          </p:nvPr>
+        </p:nvSpPr>
+        <p:spPr/>
+        <p:txBody>
+          <a:bodyPr/>
+          <a:lstStyle/>
+          <a:p>
+            <a:r>
+              <a:rPr lang="en-US" dirty="0"/>
+              <a:t>Open the dashboard Overview. Click Run 1 Jan 2017 and talk over the stages as they light up; point at Go live and the header, which now names the live model. Then Run 31 Jan 2017: rejected by the gate. Run 28 Feb 2017 after showing MLflow. Press Restore before the Score tab.</a:t>
+            </a:r>
+            <a:endParaRPr lang="en-US" dirty="0"/>
+          </a:p>
+        </p:txBody>
+      </p:sp>
+      <p:sp>
+        <p:nvSpPr>
+          <p:cNvPr id="4" name="Slide Number Placeholder 3"/>
+          <p:cNvSpPr>
+            <a:spLocks noGrp="1"/>
+          </p:cNvSpPr>
+          <p:nvPr>
+            <p:ph type="sldNum" sz="quarter" idx="10"/>
+          </p:nvPr>
+        </p:nvSpPr>
+        <p:spPr/>
+        <p:txBody>
+          <a:bodyPr/>
+          <a:lstStyle/>
+          <a:p>
+            <a:fld id="{F7021451-1387-4CA6-816F-3879F97B5CBC}" type="slidenum">
+              <a:rPr lang="en-US"/>
+              <a:t>8</a:t>
             </a:fld>
             <a:endParaRPr lang="en-US"/>
           </a:p>
@@ -5229,6 +5318,566 @@
 </p:sld>
 </file>
 
+<file path=ppt/slides/slide13.xml><?xml version="1.0" encoding="utf-8"?>
+<p:sld xmlns:a="http://schemas.openxmlformats.org/drawingml/2006/main" xmlns:r="http://schemas.openxmlformats.org/officeDocument/2006/relationships" xmlns:p="http://schemas.openxmlformats.org/presentationml/2006/main">
+  <p:cSld name="Slide 13">
+    <p:bg>
+      <p:bgPr>
+        <a:solidFill>
+          <a:srgbClr val="08090B"/>
+        </a:solidFill>
+      </p:bgPr>
+    </p:bg>
+    <p:spTree>
+      <p:nvGrpSpPr>
+        <p:cNvPr id="1" name=""/>
+        <p:cNvGrpSpPr/>
+        <p:nvPr/>
+      </p:nvGrpSpPr>
+      <p:grpSpPr>
+        <a:xfrm>
+          <a:off x="0" y="0"/>
+          <a:ext cx="0" cy="0"/>
+          <a:chOff x="0" y="0"/>
+          <a:chExt cx="0" cy="0"/>
+        </a:xfrm>
+      </p:grpSpPr>
+      <p:sp>
+        <p:nvSpPr>
+          <p:cNvPr id="2" name="Text 0"/>
+          <p:cNvSpPr txBox="1"/>
+          <p:nvPr/>
+        </p:nvSpPr>
+        <p:spPr>
+          <a:xfrm>
+            <a:off x="548640" y="411480"/>
+            <a:ext cx="8229600" cy="274320"/>
+          </a:xfrm>
+          <a:prstGeom prst="rect">
+            <a:avLst/>
+          </a:prstGeom>
+          <a:noFill/>
+          <a:ln/>
+        </p:spPr>
+        <p:txBody>
+          <a:bodyPr wrap="square" lIns="0" tIns="0" rIns="0" bIns="0" rtlCol="0" anchor="ctr"/>
+          <a:lstStyle/>
+          <a:p>
+            <a:pPr indent="0" marL="0">
+              <a:buNone/>
+            </a:pPr>
+            <a:r>
+              <a:rPr lang="en-US" sz="1100" b="1" spc="300" kern="0" dirty="0">
+                <a:solidFill>
+                  <a:srgbClr val="3ED6C0"/>
+                </a:solidFill>
+                <a:latin typeface="Arial" pitchFamily="34" charset="0"/>
+                <a:ea typeface="Arial" pitchFamily="34" charset="-122"/>
+                <a:cs typeface="Arial" pitchFamily="34" charset="-120"/>
+              </a:rPr>
+              <a:t>LIVE PIPELINE · RETRAIN, GATE, DEPLOY</a:t>
+            </a:r>
+            <a:endParaRPr lang="en-US" sz="1100" dirty="0"/>
+          </a:p>
+        </p:txBody>
+      </p:sp>
+      <p:sp>
+        <p:nvSpPr>
+          <p:cNvPr id="3" name="Text 1"/>
+          <p:cNvSpPr txBox="1"/>
+          <p:nvPr/>
+        </p:nvSpPr>
+        <p:spPr>
+          <a:xfrm>
+            <a:off x="548640" y="685800"/>
+            <a:ext cx="11094415" cy="731520"/>
+          </a:xfrm>
+          <a:prstGeom prst="rect">
+            <a:avLst/>
+          </a:prstGeom>
+          <a:noFill/>
+          <a:ln/>
+        </p:spPr>
+        <p:txBody>
+          <a:bodyPr wrap="square" lIns="0" tIns="0" rIns="0" bIns="0" rtlCol="0" anchor="ctr"/>
+          <a:lstStyle/>
+          <a:p>
+            <a:pPr indent="0" marL="0">
+              <a:buNone/>
+            </a:pPr>
+            <a:r>
+              <a:rPr lang="en-US" sz="3200" dirty="0">
+                <a:solidFill>
+                  <a:srgbClr val="F4F6F8"/>
+                </a:solidFill>
+                <a:latin typeface="Georgia" pitchFamily="34" charset="0"/>
+                <a:ea typeface="Georgia" pitchFamily="34" charset="-122"/>
+                <a:cs typeface="Georgia" pitchFamily="34" charset="-120"/>
+              </a:rPr>
+              <a:t>Press Run: it retrains on real months</a:t>
+            </a:r>
+            <a:endParaRPr lang="en-US" sz="3200" dirty="0"/>
+          </a:p>
+        </p:txBody>
+      </p:sp>
+      <p:pic>
+        <p:nvPicPr>
+          <p:cNvPr id="4" name="Image 0" descr="Dashboard Overview: the live pipeline">    </p:cNvPr>
+          <p:cNvPicPr>
+            <a:picLocks noChangeAspect="1"/>
+          </p:cNvPicPr>
+          <p:nvPr/>
+        </p:nvPicPr>
+        <p:blipFill>
+          <a:blip r:embed="rId1"/>
+          <a:stretch>
+            <a:fillRect/>
+          </a:stretch>
+        </p:blipFill>
+        <p:spPr>
+          <a:xfrm>
+            <a:off x="548640" y="1691640"/>
+            <a:ext cx="6309360" cy="4732020"/>
+          </a:xfrm>
+          <a:prstGeom prst="rect">
+            <a:avLst/>
+          </a:prstGeom>
+        </p:spPr>
+      </p:pic>
+      <p:sp>
+        <p:nvSpPr>
+          <p:cNvPr id="5" name="Shape 2"/>
+          <p:cNvSpPr/>
+          <p:nvPr/>
+        </p:nvSpPr>
+        <p:spPr>
+          <a:xfrm>
+            <a:off x="7635240" y="1783080"/>
+            <a:ext cx="420624" cy="420624"/>
+          </a:xfrm>
+          <a:prstGeom prst="ellipse">
+            <a:avLst/>
+          </a:prstGeom>
+          <a:solidFill>
+            <a:srgbClr val="123F3A"/>
+          </a:solidFill>
+          <a:ln w="15875">
+            <a:solidFill>
+              <a:srgbClr val="3ED6C0"/>
+            </a:solidFill>
+            <a:prstDash val="solid"/>
+          </a:ln>
+        </p:spPr>
+      </p:sp>
+      <p:sp>
+        <p:nvSpPr>
+          <p:cNvPr id="6" name="Text 3"/>
+          <p:cNvSpPr txBox="1"/>
+          <p:nvPr/>
+        </p:nvSpPr>
+        <p:spPr>
+          <a:xfrm>
+            <a:off x="7635240" y="1783080"/>
+            <a:ext cx="420624" cy="420624"/>
+          </a:xfrm>
+          <a:prstGeom prst="rect">
+            <a:avLst/>
+          </a:prstGeom>
+          <a:noFill/>
+          <a:ln/>
+        </p:spPr>
+        <p:txBody>
+          <a:bodyPr wrap="square" lIns="0" tIns="0" rIns="0" bIns="0" rtlCol="0" anchor="ctr"/>
+          <a:lstStyle/>
+          <a:p>
+            <a:pPr algn="ctr" indent="0" marL="0">
+              <a:buNone/>
+            </a:pPr>
+            <a:r>
+              <a:rPr lang="en-US" sz="1400" b="1" dirty="0">
+                <a:solidFill>
+                  <a:srgbClr val="3ED6C0"/>
+                </a:solidFill>
+                <a:latin typeface="Arial" pitchFamily="34" charset="0"/>
+                <a:ea typeface="Arial" pitchFamily="34" charset="-122"/>
+                <a:cs typeface="Arial" pitchFamily="34" charset="-120"/>
+              </a:rPr>
+              <a:t>1</a:t>
+            </a:r>
+            <a:endParaRPr lang="en-US" sz="1400" dirty="0"/>
+          </a:p>
+        </p:txBody>
+      </p:sp>
+      <p:sp>
+        <p:nvSpPr>
+          <p:cNvPr id="7" name="Text 4"/>
+          <p:cNvSpPr txBox="1"/>
+          <p:nvPr/>
+        </p:nvSpPr>
+        <p:spPr>
+          <a:xfrm>
+            <a:off x="8229600" y="1737360"/>
+            <a:ext cx="3474720" cy="411480"/>
+          </a:xfrm>
+          <a:prstGeom prst="rect">
+            <a:avLst/>
+          </a:prstGeom>
+          <a:noFill/>
+          <a:ln/>
+        </p:spPr>
+        <p:txBody>
+          <a:bodyPr wrap="square" lIns="0" tIns="0" rIns="0" bIns="0" rtlCol="0" anchor="ctr"/>
+          <a:lstStyle/>
+          <a:p>
+            <a:pPr indent="0" marL="0">
+              <a:buNone/>
+            </a:pPr>
+            <a:r>
+              <a:rPr lang="en-US" sz="1600" b="1" dirty="0">
+                <a:solidFill>
+                  <a:srgbClr val="F4F6F8"/>
+                </a:solidFill>
+                <a:latin typeface="Arial" pitchFamily="34" charset="0"/>
+                <a:ea typeface="Arial" pitchFamily="34" charset="-122"/>
+                <a:cs typeface="Arial" pitchFamily="34" charset="-120"/>
+              </a:rPr>
+              <a:t>Real data, the real pipeline</a:t>
+            </a:r>
+            <a:endParaRPr lang="en-US" sz="1600" dirty="0"/>
+          </a:p>
+        </p:txBody>
+      </p:sp>
+      <p:sp>
+        <p:nvSpPr>
+          <p:cNvPr id="8" name="Text 5"/>
+          <p:cNvSpPr txBox="1"/>
+          <p:nvPr/>
+        </p:nvSpPr>
+        <p:spPr>
+          <a:xfrm>
+            <a:off x="8229600" y="2167128"/>
+            <a:ext cx="3474720" cy="1005840"/>
+          </a:xfrm>
+          <a:prstGeom prst="rect">
+            <a:avLst/>
+          </a:prstGeom>
+          <a:noFill/>
+          <a:ln/>
+        </p:spPr>
+        <p:txBody>
+          <a:bodyPr wrap="square" lIns="0" tIns="0" rIns="0" bIns="0" rtlCol="0" anchor="ctr"/>
+          <a:lstStyle/>
+          <a:p>
+            <a:pPr indent="0" marL="0">
+              <a:buNone/>
+            </a:pPr>
+            <a:r>
+              <a:rPr lang="en-US" sz="1350" dirty="0">
+                <a:solidFill>
+                  <a:srgbClr val="A9B2BE"/>
+                </a:solidFill>
+                <a:latin typeface="Arial" pitchFamily="34" charset="0"/>
+                <a:ea typeface="Arial" pitchFamily="34" charset="-122"/>
+                <a:cs typeface="Arial" pitchFamily="34" charset="-120"/>
+              </a:rPr>
+              <a:t>each click replays a month of KKBox (Jan–Feb 2017) through features, validation, drift, training and evaluation</a:t>
+            </a:r>
+            <a:endParaRPr lang="en-US" sz="1350" dirty="0"/>
+          </a:p>
+        </p:txBody>
+      </p:sp>
+      <p:sp>
+        <p:nvSpPr>
+          <p:cNvPr id="9" name="Shape 6"/>
+          <p:cNvSpPr/>
+          <p:nvPr/>
+        </p:nvSpPr>
+        <p:spPr>
+          <a:xfrm>
+            <a:off x="7635240" y="3264408"/>
+            <a:ext cx="420624" cy="420624"/>
+          </a:xfrm>
+          <a:prstGeom prst="ellipse">
+            <a:avLst/>
+          </a:prstGeom>
+          <a:solidFill>
+            <a:srgbClr val="123F3A"/>
+          </a:solidFill>
+          <a:ln w="15875">
+            <a:solidFill>
+              <a:srgbClr val="3ED6C0"/>
+            </a:solidFill>
+            <a:prstDash val="solid"/>
+          </a:ln>
+        </p:spPr>
+      </p:sp>
+      <p:sp>
+        <p:nvSpPr>
+          <p:cNvPr id="10" name="Text 7"/>
+          <p:cNvSpPr txBox="1"/>
+          <p:nvPr/>
+        </p:nvSpPr>
+        <p:spPr>
+          <a:xfrm>
+            <a:off x="7635240" y="3264408"/>
+            <a:ext cx="420624" cy="420624"/>
+          </a:xfrm>
+          <a:prstGeom prst="rect">
+            <a:avLst/>
+          </a:prstGeom>
+          <a:noFill/>
+          <a:ln/>
+        </p:spPr>
+        <p:txBody>
+          <a:bodyPr wrap="square" lIns="0" tIns="0" rIns="0" bIns="0" rtlCol="0" anchor="ctr"/>
+          <a:lstStyle/>
+          <a:p>
+            <a:pPr algn="ctr" indent="0" marL="0">
+              <a:buNone/>
+            </a:pPr>
+            <a:r>
+              <a:rPr lang="en-US" sz="1400" b="1" dirty="0">
+                <a:solidFill>
+                  <a:srgbClr val="3ED6C0"/>
+                </a:solidFill>
+                <a:latin typeface="Arial" pitchFamily="34" charset="0"/>
+                <a:ea typeface="Arial" pitchFamily="34" charset="-122"/>
+                <a:cs typeface="Arial" pitchFamily="34" charset="-120"/>
+              </a:rPr>
+              <a:t>2</a:t>
+            </a:r>
+            <a:endParaRPr lang="en-US" sz="1400" dirty="0"/>
+          </a:p>
+        </p:txBody>
+      </p:sp>
+      <p:sp>
+        <p:nvSpPr>
+          <p:cNvPr id="11" name="Text 8"/>
+          <p:cNvSpPr txBox="1"/>
+          <p:nvPr/>
+        </p:nvSpPr>
+        <p:spPr>
+          <a:xfrm>
+            <a:off x="8229600" y="3218688"/>
+            <a:ext cx="3474720" cy="411480"/>
+          </a:xfrm>
+          <a:prstGeom prst="rect">
+            <a:avLst/>
+          </a:prstGeom>
+          <a:noFill/>
+          <a:ln/>
+        </p:spPr>
+        <p:txBody>
+          <a:bodyPr wrap="square" lIns="0" tIns="0" rIns="0" bIns="0" rtlCol="0" anchor="ctr"/>
+          <a:lstStyle/>
+          <a:p>
+            <a:pPr indent="0" marL="0">
+              <a:buNone/>
+            </a:pPr>
+            <a:r>
+              <a:rPr lang="en-US" sz="1600" b="1" dirty="0">
+                <a:solidFill>
+                  <a:srgbClr val="F4F6F8"/>
+                </a:solidFill>
+                <a:latin typeface="Arial" pitchFamily="34" charset="0"/>
+                <a:ea typeface="Arial" pitchFamily="34" charset="-122"/>
+                <a:cs typeface="Arial" pitchFamily="34" charset="-120"/>
+              </a:rPr>
+              <a:t>The gate decides, live</a:t>
+            </a:r>
+            <a:endParaRPr lang="en-US" sz="1600" dirty="0"/>
+          </a:p>
+        </p:txBody>
+      </p:sp>
+      <p:sp>
+        <p:nvSpPr>
+          <p:cNvPr id="12" name="Text 9"/>
+          <p:cNvSpPr txBox="1"/>
+          <p:nvPr/>
+        </p:nvSpPr>
+        <p:spPr>
+          <a:xfrm>
+            <a:off x="8229600" y="3648456"/>
+            <a:ext cx="3474720" cy="1005840"/>
+          </a:xfrm>
+          <a:prstGeom prst="rect">
+            <a:avLst/>
+          </a:prstGeom>
+          <a:noFill/>
+          <a:ln/>
+        </p:spPr>
+        <p:txBody>
+          <a:bodyPr wrap="square" lIns="0" tIns="0" rIns="0" bIns="0" rtlCol="0" anchor="ctr"/>
+          <a:lstStyle/>
+          <a:p>
+            <a:pPr indent="0" marL="0">
+              <a:buNone/>
+            </a:pPr>
+            <a:r>
+              <a:rPr lang="en-US" sz="1350" dirty="0">
+                <a:solidFill>
+                  <a:srgbClr val="A9B2BE"/>
+                </a:solidFill>
+                <a:latin typeface="Arial" pitchFamily="34" charset="0"/>
+                <a:ea typeface="Arial" pitchFamily="34" charset="-122"/>
+                <a:cs typeface="Arial" pitchFamily="34" charset="-120"/>
+              </a:rPr>
+              <a:t>month 1 promoted; month 2 rejected (+0.0001, needs +0.005); month 3 promoted (0.0568 vs 0.0489)</a:t>
+            </a:r>
+            <a:endParaRPr lang="en-US" sz="1350" dirty="0"/>
+          </a:p>
+        </p:txBody>
+      </p:sp>
+      <p:sp>
+        <p:nvSpPr>
+          <p:cNvPr id="13" name="Shape 10"/>
+          <p:cNvSpPr/>
+          <p:nvPr/>
+        </p:nvSpPr>
+        <p:spPr>
+          <a:xfrm>
+            <a:off x="7635240" y="4745736"/>
+            <a:ext cx="420624" cy="420624"/>
+          </a:xfrm>
+          <a:prstGeom prst="ellipse">
+            <a:avLst/>
+          </a:prstGeom>
+          <a:solidFill>
+            <a:srgbClr val="123F3A"/>
+          </a:solidFill>
+          <a:ln w="15875">
+            <a:solidFill>
+              <a:srgbClr val="3ED6C0"/>
+            </a:solidFill>
+            <a:prstDash val="solid"/>
+          </a:ln>
+        </p:spPr>
+      </p:sp>
+      <p:sp>
+        <p:nvSpPr>
+          <p:cNvPr id="14" name="Text 11"/>
+          <p:cNvSpPr txBox="1"/>
+          <p:nvPr/>
+        </p:nvSpPr>
+        <p:spPr>
+          <a:xfrm>
+            <a:off x="7635240" y="4745736"/>
+            <a:ext cx="420624" cy="420624"/>
+          </a:xfrm>
+          <a:prstGeom prst="rect">
+            <a:avLst/>
+          </a:prstGeom>
+          <a:noFill/>
+          <a:ln/>
+        </p:spPr>
+        <p:txBody>
+          <a:bodyPr wrap="square" lIns="0" tIns="0" rIns="0" bIns="0" rtlCol="0" anchor="ctr"/>
+          <a:lstStyle/>
+          <a:p>
+            <a:pPr algn="ctr" indent="0" marL="0">
+              <a:buNone/>
+            </a:pPr>
+            <a:r>
+              <a:rPr lang="en-US" sz="1400" b="1" dirty="0">
+                <a:solidFill>
+                  <a:srgbClr val="3ED6C0"/>
+                </a:solidFill>
+                <a:latin typeface="Arial" pitchFamily="34" charset="0"/>
+                <a:ea typeface="Arial" pitchFamily="34" charset="-122"/>
+                <a:cs typeface="Arial" pitchFamily="34" charset="-120"/>
+              </a:rPr>
+              <a:t>3</a:t>
+            </a:r>
+            <a:endParaRPr lang="en-US" sz="1400" dirty="0"/>
+          </a:p>
+        </p:txBody>
+      </p:sp>
+      <p:sp>
+        <p:nvSpPr>
+          <p:cNvPr id="15" name="Text 12"/>
+          <p:cNvSpPr txBox="1"/>
+          <p:nvPr/>
+        </p:nvSpPr>
+        <p:spPr>
+          <a:xfrm>
+            <a:off x="8229600" y="4700016"/>
+            <a:ext cx="3474720" cy="411480"/>
+          </a:xfrm>
+          <a:prstGeom prst="rect">
+            <a:avLst/>
+          </a:prstGeom>
+          <a:noFill/>
+          <a:ln/>
+        </p:spPr>
+        <p:txBody>
+          <a:bodyPr wrap="square" lIns="0" tIns="0" rIns="0" bIns="0" rtlCol="0" anchor="ctr"/>
+          <a:lstStyle/>
+          <a:p>
+            <a:pPr indent="0" marL="0">
+              <a:buNone/>
+            </a:pPr>
+            <a:r>
+              <a:rPr lang="en-US" sz="1600" b="1" dirty="0">
+                <a:solidFill>
+                  <a:srgbClr val="F4F6F8"/>
+                </a:solidFill>
+                <a:latin typeface="Arial" pitchFamily="34" charset="0"/>
+                <a:ea typeface="Arial" pitchFamily="34" charset="-122"/>
+                <a:cs typeface="Arial" pitchFamily="34" charset="-120"/>
+              </a:rPr>
+              <a:t>A win really deploys</a:t>
+            </a:r>
+            <a:endParaRPr lang="en-US" sz="1600" dirty="0"/>
+          </a:p>
+        </p:txBody>
+      </p:sp>
+      <p:sp>
+        <p:nvSpPr>
+          <p:cNvPr id="16" name="Text 13"/>
+          <p:cNvSpPr txBox="1"/>
+          <p:nvPr/>
+        </p:nvSpPr>
+        <p:spPr>
+          <a:xfrm>
+            <a:off x="8229600" y="5129784"/>
+            <a:ext cx="3474720" cy="1005840"/>
+          </a:xfrm>
+          <a:prstGeom prst="rect">
+            <a:avLst/>
+          </a:prstGeom>
+          <a:noFill/>
+          <a:ln/>
+        </p:spPr>
+        <p:txBody>
+          <a:bodyPr wrap="square" lIns="0" tIns="0" rIns="0" bIns="0" rtlCol="0" anchor="ctr"/>
+          <a:lstStyle/>
+          <a:p>
+            <a:pPr indent="0" marL="0">
+              <a:buNone/>
+            </a:pPr>
+            <a:r>
+              <a:rPr lang="en-US" sz="1350" dirty="0">
+                <a:solidFill>
+                  <a:srgbClr val="A9B2BE"/>
+                </a:solidFill>
+                <a:latin typeface="Arial" pitchFamily="34" charset="0"/>
+                <a:ea typeface="Arial" pitchFamily="34" charset="-122"/>
+                <a:cs typeface="Arial" pitchFamily="34" charset="-120"/>
+              </a:rPr>
+              <a:t>the API hot-loads the new model and MLflow moves @champion. Restore puts the tested model back</a:t>
+            </a:r>
+            <a:endParaRPr lang="en-US" sz="1350" dirty="0"/>
+          </a:p>
+        </p:txBody>
+      </p:sp>
+    </p:spTree>
+  </p:cSld>
+  <p:clrMapOvr>
+    <a:masterClrMapping/>
+  </p:clrMapOvr>
+</p:sld>
+</file>
+
 <file path=ppt/slides/slide2.xml><?xml version="1.0" encoding="utf-8"?>
 <p:sld xmlns:a="http://schemas.openxmlformats.org/drawingml/2006/main" xmlns:r="http://schemas.openxmlformats.org/officeDocument/2006/relationships" xmlns:p="http://schemas.openxmlformats.org/presentationml/2006/main">
   <p:cSld name="Slide 2">

</xml_diff>

<commit_message>
Docs: CI now deploys to Kubernetes - 8 jobs, 457 tests
The kubernetes job is green on 5b586a5, so the book, script, questions,
README, architecture notes and slides stop saying the manifests are
"written, not deployed", and describe the two bugs the deploy found.

Co-Authored-By: Claude Opus 5.5 <noreply@anthropic.com>
</commit_message>
<xml_diff>
--- a/docs/viva/slides.pptx
+++ b/docs/viva/slides.pptx
@@ -2692,7 +2692,7 @@
                 <a:ea typeface="Arial" pitchFamily="34" charset="-122"/>
                 <a:cs typeface="Arial" pitchFamily="34" charset="-120"/>
               </a:rPr>
-              <a:t>AUTOMATION · 7 GITHUB ACTIONS JOBS ON EVERY PUSH</a:t>
+              <a:t>AUTOMATION · 8 GITHUB ACTIONS JOBS ON EVERY PUSH</a:t>
             </a:r>
             <a:endParaRPr lang="en-US" sz="1100" dirty="0"/>
           </a:p>
@@ -2868,7 +2868,7 @@
                 <a:ea typeface="Arial" pitchFamily="34" charset="-122"/>
                 <a:cs typeface="Arial" pitchFamily="34" charset="-120"/>
               </a:rPr>
-              <a:t>Lint + 456 tests</a:t>
+              <a:t>Lint + 457 tests</a:t>
             </a:r>
             <a:endParaRPr lang="en-US" sz="1600" dirty="0"/>
           </a:p>
@@ -3748,7 +3748,7 @@
                 <a:ea typeface="Arial" pitchFamily="34" charset="-122"/>
                 <a:cs typeface="Arial" pitchFamily="34" charset="-120"/>
               </a:rPr>
-              <a:t>Docker image</a:t>
+              <a:t>Docker + Kubernetes</a:t>
             </a:r>
             <a:endParaRPr lang="en-US" sz="1600" dirty="0"/>
           </a:p>
@@ -3787,7 +3787,7 @@
                 <a:ea typeface="Arial" pitchFamily="34" charset="-122"/>
                 <a:cs typeface="Arial" pitchFamily="34" charset="-120"/>
               </a:rPr>
-              <a:t>built and smoke-tested</a:t>
+              <a:t>smoke-tested, then deployed to a kind cluster</a:t>
             </a:r>
             <a:endParaRPr lang="en-US" sz="1250" dirty="0"/>
           </a:p>

</xml_diff>